<commit_message>
Esclarece no slide 3 a dificuldade crescente a cada 600 metros
</commit_message>
<xml_diff>
--- a/presentation/Corre_que_Derrete_Equipe_20261015.pptx
+++ b/presentation/Corre_que_Derrete_Equipe_20261015.pptx
@@ -2,19 +2,19 @@
 <file path=ppt/presentation.xml><?xml version="1.0" encoding="utf-8"?>
 <p:presentation xmlns:p="http://schemas.openxmlformats.org/presentationml/2006/main">
   <p:sldMasterIdLst>
-    <p:sldMasterId xmlns:r="http://schemas.openxmlformats.org/officeDocument/2006/relationships" id="2147483648" r:id="R1ad924c3e4804267"/>
+    <p:sldMasterId xmlns:r="http://schemas.openxmlformats.org/officeDocument/2006/relationships" id="2147483648" r:id="R548393883b7b480e"/>
   </p:sldMasterIdLst>
   <p:notesMasterIdLst>
-    <p:notesMasterId xmlns:r="http://schemas.openxmlformats.org/officeDocument/2006/relationships" r:id="R7ea4454c99ba46d7"/>
+    <p:notesMasterId xmlns:r="http://schemas.openxmlformats.org/officeDocument/2006/relationships" r:id="Rd6a4d966fc834c09"/>
   </p:notesMasterIdLst>
   <p:sldIdLst>
-    <p:sldId xmlns:r="http://schemas.openxmlformats.org/officeDocument/2006/relationships" id="256" r:id="R3cbbcaccc72b454d"/>
-    <p:sldId xmlns:r="http://schemas.openxmlformats.org/officeDocument/2006/relationships" id="257" r:id="R3d7d032826954c3a"/>
-    <p:sldId xmlns:r="http://schemas.openxmlformats.org/officeDocument/2006/relationships" id="258" r:id="Rbcabc42c86304589"/>
-    <p:sldId xmlns:r="http://schemas.openxmlformats.org/officeDocument/2006/relationships" id="259" r:id="R4dcac49bd9d14305"/>
-    <p:sldId xmlns:r="http://schemas.openxmlformats.org/officeDocument/2006/relationships" id="260" r:id="R081e0b3786344022"/>
-    <p:sldId xmlns:r="http://schemas.openxmlformats.org/officeDocument/2006/relationships" id="261" r:id="R4dd1a92b0f604b6c"/>
-    <p:sldId xmlns:r="http://schemas.openxmlformats.org/officeDocument/2006/relationships" id="262" r:id="R5780a82beb6c4f7b"/>
+    <p:sldId xmlns:r="http://schemas.openxmlformats.org/officeDocument/2006/relationships" id="256" r:id="R0f6d960b6fae454e"/>
+    <p:sldId xmlns:r="http://schemas.openxmlformats.org/officeDocument/2006/relationships" id="257" r:id="Ra79547fa11dc4ce4"/>
+    <p:sldId xmlns:r="http://schemas.openxmlformats.org/officeDocument/2006/relationships" id="258" r:id="R4facc099e2894d14"/>
+    <p:sldId xmlns:r="http://schemas.openxmlformats.org/officeDocument/2006/relationships" id="259" r:id="Re164705af37b4cdb"/>
+    <p:sldId xmlns:r="http://schemas.openxmlformats.org/officeDocument/2006/relationships" id="260" r:id="Rc63f8f7c1a824bef"/>
+    <p:sldId xmlns:r="http://schemas.openxmlformats.org/officeDocument/2006/relationships" id="261" r:id="R1572048c78104ad9"/>
+    <p:sldId xmlns:r="http://schemas.openxmlformats.org/officeDocument/2006/relationships" id="262" r:id="R6c0ee22aa20c4f66"/>
   </p:sldIdLst>
   <p:sldSz cx="12192000" cy="6858000"/>
   <p:notesSz cx="6858000" cy="9144000"/>
@@ -633,7 +633,7 @@
           </a:p>
           <a:p xmlns:a="http://schemas.openxmlformats.org/drawingml/2006/main">
             <a:r>
-              <a:t>O calor reduz a barra com o tempo. Bater tira vinte pontos percentuais, e pegar gelo recupera até quinze, sem passar de cem. Por exemplo, um impacto com oitenta deixa sessenta. A rota tem mil e oitocentos metros em três trechos, cada vez mais rápidos. Para vencer, é preciso chegar com conservação acima de zero. Os pontos somam a distância e cem por gelo.</a:t>
+              <a:t>O calor reduz a barra com o tempo. Bater tira vinte pontos percentuais, e pegar gelo recupera até quinze, sem passar de cem. Por exemplo, um impacto com oitenta deixa sessenta. A rota tem mil e oitocentos metros em três trechos. Ao chegar aos seiscentos e aos mil e duzentos metros, a velocidade aumenta e diminui o espaço entre os obstáculos. Para vencer, é preciso chegar com conservação acima de zero. Os pontos somam a distância e cem por gelo.</a:t>
             </a:r>
           </a:p>
           <a:p xmlns:a="http://schemas.openxmlformats.org/drawingml/2006/main">
@@ -1055,7 +1055,7 @@
           <p:cNvPr id="3" name="Title">
             <a:extLst xmlns:a="http://schemas.openxmlformats.org/drawingml/2006/main">
               <a:ext uri="{FF2B5EF4-FFF2-40B4-BE49-F238E27FC236}">
-                <a16:creationId xmlns:a16="http://schemas.microsoft.com/office/drawing/2014/main" id="{2D274616-BD5B-472A-B121-1864F5B3CCF4}"/>
+                <a16:creationId xmlns:a16="http://schemas.microsoft.com/office/drawing/2014/main" id="{31C10FDF-BDE2-4B57-8865-FA32CCEB4BC2}"/>
               </a:ext>
             </a:extLst>
           </p:cNvPr>
@@ -1212,7 +1212,7 @@
           <p:cNvPr id="2" name="Subtitle">
             <a:extLst xmlns:a="http://schemas.openxmlformats.org/drawingml/2006/main">
               <a:ext uri="{FF2B5EF4-FFF2-40B4-BE49-F238E27FC236}">
-                <a16:creationId xmlns:a16="http://schemas.microsoft.com/office/drawing/2014/main" id="{B6FC45D5-3E1D-4D82-9F88-B895462703DA}"/>
+                <a16:creationId xmlns:a16="http://schemas.microsoft.com/office/drawing/2014/main" id="{E2D914FA-2CB1-4248-A3DB-F9F0ED8C2E0C}"/>
               </a:ext>
             </a:extLst>
           </p:cNvPr>
@@ -1386,7 +1386,7 @@
           <p:cNvPr id="2" name="Section title">
             <a:extLst xmlns:a="http://schemas.openxmlformats.org/drawingml/2006/main">
               <a:ext uri="{FF2B5EF4-FFF2-40B4-BE49-F238E27FC236}">
-                <a16:creationId xmlns:a16="http://schemas.microsoft.com/office/drawing/2014/main" id="{9A075C84-4952-4BD8-A27E-E07D4DD86F11}"/>
+                <a16:creationId xmlns:a16="http://schemas.microsoft.com/office/drawing/2014/main" id="{B51B9B38-08AF-486A-A775-0CA9CA0E7D11}"/>
               </a:ext>
             </a:extLst>
           </p:cNvPr>
@@ -1560,7 +1560,7 @@
           <p:cNvPr id="3" name="Title">
             <a:extLst xmlns:a="http://schemas.openxmlformats.org/drawingml/2006/main">
               <a:ext uri="{FF2B5EF4-FFF2-40B4-BE49-F238E27FC236}">
-                <a16:creationId xmlns:a16="http://schemas.microsoft.com/office/drawing/2014/main" id="{B174C311-CA5D-4A53-A3F8-93FC8A7F7A20}"/>
+                <a16:creationId xmlns:a16="http://schemas.microsoft.com/office/drawing/2014/main" id="{2CB6BE5F-8556-49AA-81EA-290449F73ED9}"/>
               </a:ext>
             </a:extLst>
           </p:cNvPr>
@@ -1717,7 +1717,7 @@
           <p:cNvPr id="2" name="Body">
             <a:extLst xmlns:a="http://schemas.openxmlformats.org/drawingml/2006/main">
               <a:ext uri="{FF2B5EF4-FFF2-40B4-BE49-F238E27FC236}">
-                <a16:creationId xmlns:a16="http://schemas.microsoft.com/office/drawing/2014/main" id="{0EA195DE-FC60-4DB0-B15C-630AE386A519}"/>
+                <a16:creationId xmlns:a16="http://schemas.microsoft.com/office/drawing/2014/main" id="{75FBDCDC-7A49-4494-9B01-2A1A492E9EF6}"/>
               </a:ext>
             </a:extLst>
           </p:cNvPr>
@@ -1891,7 +1891,7 @@
           <p:cNvPr id="4" name="Title">
             <a:extLst xmlns:a="http://schemas.openxmlformats.org/drawingml/2006/main">
               <a:ext uri="{FF2B5EF4-FFF2-40B4-BE49-F238E27FC236}">
-                <a16:creationId xmlns:a16="http://schemas.microsoft.com/office/drawing/2014/main" id="{DB0D50FE-D0C5-4536-ABE1-D6344F6F1EC5}"/>
+                <a16:creationId xmlns:a16="http://schemas.microsoft.com/office/drawing/2014/main" id="{F621C1AD-DCED-40B8-8D41-627406CC4C63}"/>
               </a:ext>
             </a:extLst>
           </p:cNvPr>
@@ -2048,7 +2048,7 @@
           <p:cNvPr id="2" name="Left column">
             <a:extLst xmlns:a="http://schemas.openxmlformats.org/drawingml/2006/main">
               <a:ext uri="{FF2B5EF4-FFF2-40B4-BE49-F238E27FC236}">
-                <a16:creationId xmlns:a16="http://schemas.microsoft.com/office/drawing/2014/main" id="{8176B630-6EDE-4651-A72C-34DEBFE2D773}"/>
+                <a16:creationId xmlns:a16="http://schemas.microsoft.com/office/drawing/2014/main" id="{1D79E180-075E-43C5-B5CF-5535948B725F}"/>
               </a:ext>
             </a:extLst>
           </p:cNvPr>
@@ -2205,7 +2205,7 @@
           <p:cNvPr id="3" name="Right column">
             <a:extLst xmlns:a="http://schemas.openxmlformats.org/drawingml/2006/main">
               <a:ext uri="{FF2B5EF4-FFF2-40B4-BE49-F238E27FC236}">
-                <a16:creationId xmlns:a16="http://schemas.microsoft.com/office/drawing/2014/main" id="{F21633B5-454D-4930-A063-AC473A3BB95A}"/>
+                <a16:creationId xmlns:a16="http://schemas.microsoft.com/office/drawing/2014/main" id="{4CD6C8CE-8536-41AE-8AB0-3282C5B1581F}"/>
               </a:ext>
             </a:extLst>
           </p:cNvPr>
@@ -2379,7 +2379,7 @@
           <p:cNvPr id="3" name="Title">
             <a:extLst xmlns:a="http://schemas.openxmlformats.org/drawingml/2006/main">
               <a:ext uri="{FF2B5EF4-FFF2-40B4-BE49-F238E27FC236}">
-                <a16:creationId xmlns:a16="http://schemas.microsoft.com/office/drawing/2014/main" id="{DB2C0B70-A858-4E12-A677-B5A84B2CB840}"/>
+                <a16:creationId xmlns:a16="http://schemas.microsoft.com/office/drawing/2014/main" id="{94077CA9-1432-4F7F-9FA7-28600991B4AB}"/>
               </a:ext>
             </a:extLst>
           </p:cNvPr>
@@ -2536,7 +2536,7 @@
           <p:cNvPr id="2" name="Left column">
             <a:extLst xmlns:a="http://schemas.openxmlformats.org/drawingml/2006/main">
               <a:ext uri="{FF2B5EF4-FFF2-40B4-BE49-F238E27FC236}">
-                <a16:creationId xmlns:a16="http://schemas.microsoft.com/office/drawing/2014/main" id="{FDC4CB0E-12C2-4E14-97B8-0362F003646B}"/>
+                <a16:creationId xmlns:a16="http://schemas.microsoft.com/office/drawing/2014/main" id="{7B9CA8DF-1273-4705-B761-701C97319108}"/>
               </a:ext>
             </a:extLst>
           </p:cNvPr>
@@ -2731,12 +2731,12 @@
   </p:cSld>
   <p:clrMap bg1="lt1" tx1="dk1" bg2="lt2" tx2="dk2" accent1="accent1" accent2="accent2" accent3="accent3" accent4="accent4" accent5="accent5" accent6="accent6" hlink="hlink" folHlink="folHlink"/>
   <p:sldLayoutIdLst>
-    <p:sldLayoutId xmlns:r="http://schemas.openxmlformats.org/officeDocument/2006/relationships" id="2147483649" r:id="Rdfe9fa1b4a724aea"/>
-    <p:sldLayoutId xmlns:r="http://schemas.openxmlformats.org/officeDocument/2006/relationships" id="2147483650" r:id="R9231398769854e5c"/>
-    <p:sldLayoutId xmlns:r="http://schemas.openxmlformats.org/officeDocument/2006/relationships" id="2147483651" r:id="R574a3cab62a445db"/>
-    <p:sldLayoutId xmlns:r="http://schemas.openxmlformats.org/officeDocument/2006/relationships" id="2147483652" r:id="R7180337654ca47e6"/>
-    <p:sldLayoutId xmlns:r="http://schemas.openxmlformats.org/officeDocument/2006/relationships" id="2147483653" r:id="R9d047a5ee83d4b9d"/>
-    <p:sldLayoutId xmlns:r="http://schemas.openxmlformats.org/officeDocument/2006/relationships" id="2147483654" r:id="R753159e7f60a42c9"/>
+    <p:sldLayoutId xmlns:r="http://schemas.openxmlformats.org/officeDocument/2006/relationships" id="2147483649" r:id="R149b302c1fe14410"/>
+    <p:sldLayoutId xmlns:r="http://schemas.openxmlformats.org/officeDocument/2006/relationships" id="2147483650" r:id="R12bf642921b94e9b"/>
+    <p:sldLayoutId xmlns:r="http://schemas.openxmlformats.org/officeDocument/2006/relationships" id="2147483651" r:id="R6278e5edae4e48c2"/>
+    <p:sldLayoutId xmlns:r="http://schemas.openxmlformats.org/officeDocument/2006/relationships" id="2147483652" r:id="R6b3a7fe5056346f4"/>
+    <p:sldLayoutId xmlns:r="http://schemas.openxmlformats.org/officeDocument/2006/relationships" id="2147483653" r:id="R5b290155b1cd4359"/>
+    <p:sldLayoutId xmlns:r="http://schemas.openxmlformats.org/officeDocument/2006/relationships" id="2147483654" r:id="R23f25edcc1ee4064"/>
   </p:sldLayoutIdLst>
   <p:txStyles>
     <p:titleStyle>
@@ -3287,7 +3287,7 @@
           <p:cNvPr id="6" name="">
             <a:extLst xmlns:a="http://schemas.openxmlformats.org/drawingml/2006/main">
               <a:ext uri="{FF2B5EF4-FFF2-40B4-BE49-F238E27FC236}">
-                <a16:creationId xmlns:a16="http://schemas.microsoft.com/office/drawing/2014/main" id="{4A6931F2-2AAC-4301-9963-E492BA067A5F}"/>
+                <a16:creationId xmlns:a16="http://schemas.microsoft.com/office/drawing/2014/main" id="{AFD63064-80E1-47DC-9C91-DE747474EBEE}"/>
               </a:ext>
             </a:extLst>
           </p:cNvPr>
@@ -3356,7 +3356,7 @@
           <p:cNvPr id="2" name="">
             <a:extLst xmlns:a="http://schemas.openxmlformats.org/drawingml/2006/main">
               <a:ext uri="{FF2B5EF4-FFF2-40B4-BE49-F238E27FC236}">
-                <a16:creationId xmlns:a16="http://schemas.microsoft.com/office/drawing/2014/main" id="{A2F87812-282C-4200-91E4-75BAA93DFA99}"/>
+                <a16:creationId xmlns:a16="http://schemas.microsoft.com/office/drawing/2014/main" id="{7D1C45A1-547E-4BF5-936A-AFD58A0C8A03}"/>
               </a:ext>
             </a:extLst>
           </p:cNvPr>
@@ -3425,7 +3425,7 @@
           <p:cNvPr id="3" name="">
             <a:extLst xmlns:a="http://schemas.openxmlformats.org/drawingml/2006/main">
               <a:ext uri="{FF2B5EF4-FFF2-40B4-BE49-F238E27FC236}">
-                <a16:creationId xmlns:a16="http://schemas.microsoft.com/office/drawing/2014/main" id="{7655F3F0-586C-4162-8991-1DAEE9870CA2}"/>
+                <a16:creationId xmlns:a16="http://schemas.microsoft.com/office/drawing/2014/main" id="{2863CF29-4941-4432-A114-77A0154BFA76}"/>
               </a:ext>
             </a:extLst>
           </p:cNvPr>
@@ -3540,7 +3540,7 @@
           <p:cNvPr id="4" name="">
             <a:extLst xmlns:a="http://schemas.openxmlformats.org/drawingml/2006/main">
               <a:ext uri="{FF2B5EF4-FFF2-40B4-BE49-F238E27FC236}">
-                <a16:creationId xmlns:a16="http://schemas.microsoft.com/office/drawing/2014/main" id="{FA16CCDC-20B6-4096-A153-3FDD3C2E67B9}"/>
+                <a16:creationId xmlns:a16="http://schemas.microsoft.com/office/drawing/2014/main" id="{262F34B1-DAE0-4DB4-8895-2B5D17EA3863}"/>
               </a:ext>
             </a:extLst>
           </p:cNvPr>
@@ -3655,7 +3655,7 @@
           <p:cNvPr id="5" name="">
             <a:extLst xmlns:a="http://schemas.openxmlformats.org/drawingml/2006/main">
               <a:ext uri="{FF2B5EF4-FFF2-40B4-BE49-F238E27FC236}">
-                <a16:creationId xmlns:a16="http://schemas.microsoft.com/office/drawing/2014/main" id="{4B663C8D-7260-415E-A5B3-BA7C16495454}"/>
+                <a16:creationId xmlns:a16="http://schemas.microsoft.com/office/drawing/2014/main" id="{CF99DDCE-C27A-4F02-A45B-E7D2491FD414}"/>
               </a:ext>
             </a:extLst>
           </p:cNvPr>
@@ -3665,7 +3665,7 @@
           <p:nvPr/>
         </p:nvPicPr>
         <p:blipFill>
-          <a:blip xmlns:r="http://schemas.openxmlformats.org/officeDocument/2006/relationships" xmlns:a="http://schemas.openxmlformats.org/drawingml/2006/main" r:embed="R7535c247ea5843a8"/>
+          <a:blip xmlns:r="http://schemas.openxmlformats.org/officeDocument/2006/relationships" xmlns:a="http://schemas.openxmlformats.org/drawingml/2006/main" r:embed="R4c98bf847ad64cba"/>
           <a:stretch xmlns:a="http://schemas.openxmlformats.org/drawingml/2006/main"/>
         </p:blipFill>
         <p:spPr>
@@ -3681,7 +3681,7 @@
     </p:spTree>
     <p:extLst>
       <p:ext uri="{BB962C8B-B14F-4D97-AF65-F5344CB8AC3E}">
-        <p14:creationId xmlns:p14="http://schemas.microsoft.com/office/powerpoint/2010/main" val="799466445"/>
+        <p14:creationId xmlns:p14="http://schemas.microsoft.com/office/powerpoint/2010/main" val="1843058390"/>
       </p:ext>
     </p:extLst>
   </p:cSld>
@@ -3712,7 +3712,7 @@
           <p:cNvPr id="6" name="">
             <a:extLst xmlns:a="http://schemas.openxmlformats.org/drawingml/2006/main">
               <a:ext uri="{FF2B5EF4-FFF2-40B4-BE49-F238E27FC236}">
-                <a16:creationId xmlns:a16="http://schemas.microsoft.com/office/drawing/2014/main" id="{756DEEDB-2B1A-4823-859E-9B9B537A05DE}"/>
+                <a16:creationId xmlns:a16="http://schemas.microsoft.com/office/drawing/2014/main" id="{BF339C6A-1E20-4CC3-9C84-48E40865125C}"/>
               </a:ext>
             </a:extLst>
           </p:cNvPr>
@@ -3781,7 +3781,7 @@
           <p:cNvPr id="2" name="">
             <a:extLst xmlns:a="http://schemas.openxmlformats.org/drawingml/2006/main">
               <a:ext uri="{FF2B5EF4-FFF2-40B4-BE49-F238E27FC236}">
-                <a16:creationId xmlns:a16="http://schemas.microsoft.com/office/drawing/2014/main" id="{1B4FE1D3-1907-445C-A24D-C3E978856611}"/>
+                <a16:creationId xmlns:a16="http://schemas.microsoft.com/office/drawing/2014/main" id="{A05B2DB8-41A4-4236-AE82-90EDE123A1D8}"/>
               </a:ext>
             </a:extLst>
           </p:cNvPr>
@@ -3850,7 +3850,7 @@
           <p:cNvPr id="3" name="">
             <a:extLst xmlns:a="http://schemas.openxmlformats.org/drawingml/2006/main">
               <a:ext uri="{FF2B5EF4-FFF2-40B4-BE49-F238E27FC236}">
-                <a16:creationId xmlns:a16="http://schemas.microsoft.com/office/drawing/2014/main" id="{33B5C079-12F4-4F46-A253-C8A89F0DD013}"/>
+                <a16:creationId xmlns:a16="http://schemas.microsoft.com/office/drawing/2014/main" id="{67F69E58-FEF7-4F02-A34F-DDC842A97036}"/>
               </a:ext>
             </a:extLst>
           </p:cNvPr>
@@ -3993,7 +3993,7 @@
           <p:cNvPr id="4" name="">
             <a:extLst xmlns:a="http://schemas.openxmlformats.org/drawingml/2006/main">
               <a:ext uri="{FF2B5EF4-FFF2-40B4-BE49-F238E27FC236}">
-                <a16:creationId xmlns:a16="http://schemas.microsoft.com/office/drawing/2014/main" id="{8ED5CED6-7764-4294-A11C-A274842F9BCC}"/>
+                <a16:creationId xmlns:a16="http://schemas.microsoft.com/office/drawing/2014/main" id="{039A118D-C266-4F52-8B50-1C591CC5F86E}"/>
               </a:ext>
             </a:extLst>
           </p:cNvPr>
@@ -4108,7 +4108,7 @@
           <p:cNvPr id="5" name="">
             <a:extLst xmlns:a="http://schemas.openxmlformats.org/drawingml/2006/main">
               <a:ext uri="{FF2B5EF4-FFF2-40B4-BE49-F238E27FC236}">
-                <a16:creationId xmlns:a16="http://schemas.microsoft.com/office/drawing/2014/main" id="{96329649-CB58-4C8D-A3F1-4905B9FC6046}"/>
+                <a16:creationId xmlns:a16="http://schemas.microsoft.com/office/drawing/2014/main" id="{65C66954-6523-40EC-AB96-8ACF36BD6AE6}"/>
               </a:ext>
             </a:extLst>
           </p:cNvPr>
@@ -4118,7 +4118,7 @@
           <p:nvPr/>
         </p:nvPicPr>
         <p:blipFill>
-          <a:blip xmlns:r="http://schemas.openxmlformats.org/officeDocument/2006/relationships" xmlns:a="http://schemas.openxmlformats.org/drawingml/2006/main" r:embed="Raebd8e3ff6f94566"/>
+          <a:blip xmlns:r="http://schemas.openxmlformats.org/officeDocument/2006/relationships" xmlns:a="http://schemas.openxmlformats.org/drawingml/2006/main" r:embed="R9891d7a17db742d8"/>
           <a:stretch xmlns:a="http://schemas.openxmlformats.org/drawingml/2006/main"/>
         </p:blipFill>
         <p:spPr>
@@ -4134,7 +4134,7 @@
     </p:spTree>
     <p:extLst>
       <p:ext uri="{BB962C8B-B14F-4D97-AF65-F5344CB8AC3E}">
-        <p14:creationId xmlns:p14="http://schemas.microsoft.com/office/powerpoint/2010/main" val="2064444805"/>
+        <p14:creationId xmlns:p14="http://schemas.microsoft.com/office/powerpoint/2010/main" val="1804500904"/>
       </p:ext>
     </p:extLst>
   </p:cSld>
@@ -4165,7 +4165,7 @@
           <p:cNvPr id="7" name="">
             <a:extLst xmlns:a="http://schemas.openxmlformats.org/drawingml/2006/main">
               <a:ext uri="{FF2B5EF4-FFF2-40B4-BE49-F238E27FC236}">
-                <a16:creationId xmlns:a16="http://schemas.microsoft.com/office/drawing/2014/main" id="{724F66CC-1746-4DBF-83E8-6D49E7181566}"/>
+                <a16:creationId xmlns:a16="http://schemas.microsoft.com/office/drawing/2014/main" id="{1718E479-EC58-4650-B5DE-CA3BDC0FDF97}"/>
               </a:ext>
             </a:extLst>
           </p:cNvPr>
@@ -4234,7 +4234,7 @@
           <p:cNvPr id="2" name="">
             <a:extLst xmlns:a="http://schemas.openxmlformats.org/drawingml/2006/main">
               <a:ext uri="{FF2B5EF4-FFF2-40B4-BE49-F238E27FC236}">
-                <a16:creationId xmlns:a16="http://schemas.microsoft.com/office/drawing/2014/main" id="{38EAF7C9-0D0F-4705-8E21-B259F3638C48}"/>
+                <a16:creationId xmlns:a16="http://schemas.microsoft.com/office/drawing/2014/main" id="{8F822406-C9E6-4B31-B4CC-EF770295347E}"/>
               </a:ext>
             </a:extLst>
           </p:cNvPr>
@@ -4303,7 +4303,7 @@
           <p:cNvPr id="3" name="">
             <a:extLst xmlns:a="http://schemas.openxmlformats.org/drawingml/2006/main">
               <a:ext uri="{FF2B5EF4-FFF2-40B4-BE49-F238E27FC236}">
-                <a16:creationId xmlns:a16="http://schemas.microsoft.com/office/drawing/2014/main" id="{A5ABDC22-C29E-48D2-B5F9-839219F36756}"/>
+                <a16:creationId xmlns:a16="http://schemas.microsoft.com/office/drawing/2014/main" id="{B8C72D34-B559-49A2-B5D9-EB6FCFB307B5}"/>
               </a:ext>
             </a:extLst>
           </p:cNvPr>
@@ -4441,7 +4441,7 @@
           <p:cNvPr id="4" name="">
             <a:extLst xmlns:a="http://schemas.openxmlformats.org/drawingml/2006/main">
               <a:ext uri="{FF2B5EF4-FFF2-40B4-BE49-F238E27FC236}">
-                <a16:creationId xmlns:a16="http://schemas.microsoft.com/office/drawing/2014/main" id="{A6BB3AF7-E62D-4EE1-B6F7-B664F3B59810}"/>
+                <a16:creationId xmlns:a16="http://schemas.microsoft.com/office/drawing/2014/main" id="{702C6B53-5FB5-4376-899D-5AC1463C7CD4}"/>
               </a:ext>
             </a:extLst>
           </p:cNvPr>
@@ -4579,7 +4579,7 @@
           <p:cNvPr id="5" name="">
             <a:extLst xmlns:a="http://schemas.openxmlformats.org/drawingml/2006/main">
               <a:ext uri="{FF2B5EF4-FFF2-40B4-BE49-F238E27FC236}">
-                <a16:creationId xmlns:a16="http://schemas.microsoft.com/office/drawing/2014/main" id="{1C1F8629-ACCE-44D9-B3E4-8D7851F128C1}"/>
+                <a16:creationId xmlns:a16="http://schemas.microsoft.com/office/drawing/2014/main" id="{0FF93D83-1B98-45C6-939F-1A28ABEC63ED}"/>
               </a:ext>
             </a:extLst>
           </p:cNvPr>
@@ -4590,8 +4590,8 @@
         </p:nvSpPr>
         <p:spPr>
           <a:xfrm xmlns:a="http://schemas.openxmlformats.org/drawingml/2006/main">
-            <a:off x="609600" y="4295775"/>
-            <a:ext cx="10858500" cy="1009650"/>
+            <a:off x="609600" y="4105275"/>
+            <a:ext cx="10858500" cy="1266825"/>
           </a:xfrm>
           <a:prstGeom xmlns:a="http://schemas.openxmlformats.org/drawingml/2006/main" prst="rect">
             <a:avLst/>
@@ -4661,7 +4661,30 @@
                 <a:ea typeface="DejaVu Sans"/>
                 <a:cs typeface="DejaVu Sans"/>
               </a:rPr>
-              <a:t>Mais velocidade e obstáculos mais próximos</a:t>
+              <a:t>A cada 600 metros, a corrida fica mais rápida</a:t>
+            </a:r>
+          </a:p>
+          <a:p xmlns:a="http://schemas.openxmlformats.org/drawingml/2006/main">
+            <a:pPr>
+              <a:defRPr sz="2400" b="1">
+                <a:solidFill>
+                  <a:srgbClr val="275F83"/>
+                </a:solidFill>
+                <a:latin typeface="DejaVu Sans"/>
+                <a:ea typeface="DejaVu Sans"/>
+                <a:cs typeface="DejaVu Sans"/>
+              </a:defRPr>
+            </a:pPr>
+            <a:r>
+              <a:rPr sz="2400" b="1">
+                <a:solidFill>
+                  <a:srgbClr val="275F83"/>
+                </a:solidFill>
+                <a:latin typeface="DejaVu Sans"/>
+                <a:ea typeface="DejaVu Sans"/>
+                <a:cs typeface="DejaVu Sans"/>
+              </a:rPr>
+              <a:t>e diminui o espaço entre os obstáculos.</a:t>
             </a:r>
           </a:p>
         </p:txBody>
@@ -4671,7 +4694,7 @@
           <p:cNvPr id="6" name="">
             <a:extLst xmlns:a="http://schemas.openxmlformats.org/drawingml/2006/main">
               <a:ext uri="{FF2B5EF4-FFF2-40B4-BE49-F238E27FC236}">
-                <a16:creationId xmlns:a16="http://schemas.microsoft.com/office/drawing/2014/main" id="{993B8429-1F93-4BC5-B217-6D544A3D2C83}"/>
+                <a16:creationId xmlns:a16="http://schemas.microsoft.com/office/drawing/2014/main" id="{A5F69378-EB3B-422E-B4B8-D8DF855B48A3}"/>
               </a:ext>
             </a:extLst>
           </p:cNvPr>
@@ -4761,7 +4784,7 @@
     </p:spTree>
     <p:extLst>
       <p:ext uri="{BB962C8B-B14F-4D97-AF65-F5344CB8AC3E}">
-        <p14:creationId xmlns:p14="http://schemas.microsoft.com/office/powerpoint/2010/main" val="1691203680"/>
+        <p14:creationId xmlns:p14="http://schemas.microsoft.com/office/powerpoint/2010/main" val="2086348275"/>
       </p:ext>
     </p:extLst>
   </p:cSld>
@@ -4792,7 +4815,7 @@
           <p:cNvPr id="9" name="">
             <a:extLst xmlns:a="http://schemas.openxmlformats.org/drawingml/2006/main">
               <a:ext uri="{FF2B5EF4-FFF2-40B4-BE49-F238E27FC236}">
-                <a16:creationId xmlns:a16="http://schemas.microsoft.com/office/drawing/2014/main" id="{62A24E8A-E00A-4519-9695-255E80708C9F}"/>
+                <a16:creationId xmlns:a16="http://schemas.microsoft.com/office/drawing/2014/main" id="{D9D56A4F-CCC6-4DC9-BABE-DEE9CBF68333}"/>
               </a:ext>
             </a:extLst>
           </p:cNvPr>
@@ -4825,7 +4848,7 @@
           <p:cNvPr id="8" name="">
             <a:extLst xmlns:a="http://schemas.openxmlformats.org/drawingml/2006/main">
               <a:ext uri="{FF2B5EF4-FFF2-40B4-BE49-F238E27FC236}">
-                <a16:creationId xmlns:a16="http://schemas.microsoft.com/office/drawing/2014/main" id="{BBC8D208-B38A-4B93-82CC-01227DB8773A}"/>
+                <a16:creationId xmlns:a16="http://schemas.microsoft.com/office/drawing/2014/main" id="{C32E2FB7-951B-4734-8E29-DE1773CE4014}"/>
               </a:ext>
             </a:extLst>
           </p:cNvPr>
@@ -4858,7 +4881,7 @@
           <p:cNvPr id="7" name="">
             <a:extLst xmlns:a="http://schemas.openxmlformats.org/drawingml/2006/main">
               <a:ext uri="{FF2B5EF4-FFF2-40B4-BE49-F238E27FC236}">
-                <a16:creationId xmlns:a16="http://schemas.microsoft.com/office/drawing/2014/main" id="{7026317C-05B8-4AFE-B385-C5C64091DA5C}"/>
+                <a16:creationId xmlns:a16="http://schemas.microsoft.com/office/drawing/2014/main" id="{5D8ACADB-A8FE-4358-9614-7AAEDEF6F675}"/>
               </a:ext>
             </a:extLst>
           </p:cNvPr>
@@ -4890,7 +4913,7 @@
           <p:cNvPr id="15" name="">
             <a:extLst xmlns:a="http://schemas.openxmlformats.org/drawingml/2006/main">
               <a:ext uri="{FF2B5EF4-FFF2-40B4-BE49-F238E27FC236}">
-                <a16:creationId xmlns:a16="http://schemas.microsoft.com/office/drawing/2014/main" id="{9C494F90-D2C6-429D-AAE9-961FFF8D911F}"/>
+                <a16:creationId xmlns:a16="http://schemas.microsoft.com/office/drawing/2014/main" id="{C0F46653-1817-4F7A-A5AA-43F663BA0075}"/>
               </a:ext>
             </a:extLst>
           </p:cNvPr>
@@ -4959,7 +4982,7 @@
           <p:cNvPr id="2" name="">
             <a:extLst xmlns:a="http://schemas.openxmlformats.org/drawingml/2006/main">
               <a:ext uri="{FF2B5EF4-FFF2-40B4-BE49-F238E27FC236}">
-                <a16:creationId xmlns:a16="http://schemas.microsoft.com/office/drawing/2014/main" id="{0490E405-5362-4963-8AAB-22AB812AACAA}"/>
+                <a16:creationId xmlns:a16="http://schemas.microsoft.com/office/drawing/2014/main" id="{2BC88C1F-9D07-4078-8CF2-8094CEE26080}"/>
               </a:ext>
             </a:extLst>
           </p:cNvPr>
@@ -5028,7 +5051,7 @@
           <p:cNvPr id="3" name="">
             <a:extLst xmlns:a="http://schemas.openxmlformats.org/drawingml/2006/main">
               <a:ext uri="{FF2B5EF4-FFF2-40B4-BE49-F238E27FC236}">
-                <a16:creationId xmlns:a16="http://schemas.microsoft.com/office/drawing/2014/main" id="{0DDC8B51-27F4-475C-BF97-58F34A9CFECF}"/>
+                <a16:creationId xmlns:a16="http://schemas.microsoft.com/office/drawing/2014/main" id="{7D3ACFFC-2B2D-4D53-9A5E-8C98C5B8243F}"/>
               </a:ext>
             </a:extLst>
           </p:cNvPr>
@@ -5099,7 +5122,7 @@
           <p:cNvPr id="4" name="">
             <a:extLst xmlns:a="http://schemas.openxmlformats.org/drawingml/2006/main">
               <a:ext uri="{FF2B5EF4-FFF2-40B4-BE49-F238E27FC236}">
-                <a16:creationId xmlns:a16="http://schemas.microsoft.com/office/drawing/2014/main" id="{3918C05E-6B2C-45A0-BD06-E7C657BEB2D5}"/>
+                <a16:creationId xmlns:a16="http://schemas.microsoft.com/office/drawing/2014/main" id="{FFB1AECF-E34B-4C61-99D0-681C849E996B}"/>
               </a:ext>
             </a:extLst>
           </p:cNvPr>
@@ -5170,7 +5193,7 @@
           <p:cNvPr id="5" name="">
             <a:extLst xmlns:a="http://schemas.openxmlformats.org/drawingml/2006/main">
               <a:ext uri="{FF2B5EF4-FFF2-40B4-BE49-F238E27FC236}">
-                <a16:creationId xmlns:a16="http://schemas.microsoft.com/office/drawing/2014/main" id="{BAA9C532-76FC-4A7B-A31F-6AEF6B8AA349}"/>
+                <a16:creationId xmlns:a16="http://schemas.microsoft.com/office/drawing/2014/main" id="{E3B8AEE1-D741-48CD-8D60-CF7EEE31D759}"/>
               </a:ext>
             </a:extLst>
           </p:cNvPr>
@@ -5241,7 +5264,7 @@
           <p:cNvPr id="6" name="">
             <a:extLst xmlns:a="http://schemas.openxmlformats.org/drawingml/2006/main">
               <a:ext uri="{FF2B5EF4-FFF2-40B4-BE49-F238E27FC236}">
-                <a16:creationId xmlns:a16="http://schemas.microsoft.com/office/drawing/2014/main" id="{8E78D168-527B-4878-AE55-383415235705}"/>
+                <a16:creationId xmlns:a16="http://schemas.microsoft.com/office/drawing/2014/main" id="{945474B7-E6EB-437A-95A4-2C2CEF445927}"/>
               </a:ext>
             </a:extLst>
           </p:cNvPr>
@@ -5312,7 +5335,7 @@
           <p:cNvPr id="10" name="">
             <a:extLst xmlns:a="http://schemas.openxmlformats.org/drawingml/2006/main">
               <a:ext uri="{FF2B5EF4-FFF2-40B4-BE49-F238E27FC236}">
-                <a16:creationId xmlns:a16="http://schemas.microsoft.com/office/drawing/2014/main" id="{991D803E-C909-46A8-A99B-E328CCF8B6ED}"/>
+                <a16:creationId xmlns:a16="http://schemas.microsoft.com/office/drawing/2014/main" id="{49F13693-0660-46E0-B23D-584C63A4020F}"/>
               </a:ext>
             </a:extLst>
           </p:cNvPr>
@@ -5381,7 +5404,7 @@
           <p:cNvPr id="11" name="">
             <a:extLst xmlns:a="http://schemas.openxmlformats.org/drawingml/2006/main">
               <a:ext uri="{FF2B5EF4-FFF2-40B4-BE49-F238E27FC236}">
-                <a16:creationId xmlns:a16="http://schemas.microsoft.com/office/drawing/2014/main" id="{FBFA46FB-3387-49BD-B4DA-1009F74564CC}"/>
+                <a16:creationId xmlns:a16="http://schemas.microsoft.com/office/drawing/2014/main" id="{1D514914-9462-406A-A4DC-6A4481292701}"/>
               </a:ext>
             </a:extLst>
           </p:cNvPr>
@@ -5450,7 +5473,7 @@
           <p:cNvPr id="12" name="">
             <a:extLst xmlns:a="http://schemas.openxmlformats.org/drawingml/2006/main">
               <a:ext uri="{FF2B5EF4-FFF2-40B4-BE49-F238E27FC236}">
-                <a16:creationId xmlns:a16="http://schemas.microsoft.com/office/drawing/2014/main" id="{BE9D946A-0E89-42CC-B166-5DA9F68B6469}"/>
+                <a16:creationId xmlns:a16="http://schemas.microsoft.com/office/drawing/2014/main" id="{7FFD1361-1F86-4FC6-AE5A-C71D08921330}"/>
               </a:ext>
             </a:extLst>
           </p:cNvPr>
@@ -5519,7 +5542,7 @@
           <p:cNvPr id="13" name="">
             <a:extLst xmlns:a="http://schemas.openxmlformats.org/drawingml/2006/main">
               <a:ext uri="{FF2B5EF4-FFF2-40B4-BE49-F238E27FC236}">
-                <a16:creationId xmlns:a16="http://schemas.microsoft.com/office/drawing/2014/main" id="{66954529-2396-4595-8C7E-7CA07B527580}"/>
+                <a16:creationId xmlns:a16="http://schemas.microsoft.com/office/drawing/2014/main" id="{0020722B-5EFC-48C5-AB6A-854CC6159E86}"/>
               </a:ext>
             </a:extLst>
           </p:cNvPr>
@@ -5634,7 +5657,7 @@
           <p:cNvPr id="14" name="">
             <a:extLst xmlns:a="http://schemas.openxmlformats.org/drawingml/2006/main">
               <a:ext uri="{FF2B5EF4-FFF2-40B4-BE49-F238E27FC236}">
-                <a16:creationId xmlns:a16="http://schemas.microsoft.com/office/drawing/2014/main" id="{BFF32FFC-C977-4170-9148-D87FD7450771}"/>
+                <a16:creationId xmlns:a16="http://schemas.microsoft.com/office/drawing/2014/main" id="{1601FD40-370A-4E1B-9F19-A5989D28860F}"/>
               </a:ext>
             </a:extLst>
           </p:cNvPr>
@@ -5701,7 +5724,7 @@
     </p:spTree>
     <p:extLst>
       <p:ext uri="{BB962C8B-B14F-4D97-AF65-F5344CB8AC3E}">
-        <p14:creationId xmlns:p14="http://schemas.microsoft.com/office/powerpoint/2010/main" val="187808041"/>
+        <p14:creationId xmlns:p14="http://schemas.microsoft.com/office/powerpoint/2010/main" val="1219615934"/>
       </p:ext>
     </p:extLst>
   </p:cSld>
@@ -5732,7 +5755,7 @@
           <p:cNvPr id="15" name="">
             <a:extLst xmlns:a="http://schemas.openxmlformats.org/drawingml/2006/main">
               <a:ext uri="{FF2B5EF4-FFF2-40B4-BE49-F238E27FC236}">
-                <a16:creationId xmlns:a16="http://schemas.microsoft.com/office/drawing/2014/main" id="{5C7AADA1-D973-4E16-9A4D-A21780F17743}"/>
+                <a16:creationId xmlns:a16="http://schemas.microsoft.com/office/drawing/2014/main" id="{3E3BD4FD-68FF-4030-9B06-DA303D127DF4}"/>
               </a:ext>
             </a:extLst>
           </p:cNvPr>
@@ -5801,7 +5824,7 @@
           <p:cNvPr id="2" name="">
             <a:extLst xmlns:a="http://schemas.openxmlformats.org/drawingml/2006/main">
               <a:ext uri="{FF2B5EF4-FFF2-40B4-BE49-F238E27FC236}">
-                <a16:creationId xmlns:a16="http://schemas.microsoft.com/office/drawing/2014/main" id="{EF94554A-8615-4CA6-9BB5-638D559A03FD}"/>
+                <a16:creationId xmlns:a16="http://schemas.microsoft.com/office/drawing/2014/main" id="{82D781E1-FA29-4A84-A381-6F62507B892A}"/>
               </a:ext>
             </a:extLst>
           </p:cNvPr>
@@ -5870,7 +5893,7 @@
           <p:cNvPr id="3" name="">
             <a:extLst xmlns:a="http://schemas.openxmlformats.org/drawingml/2006/main">
               <a:ext uri="{FF2B5EF4-FFF2-40B4-BE49-F238E27FC236}">
-                <a16:creationId xmlns:a16="http://schemas.microsoft.com/office/drawing/2014/main" id="{B5475A9A-6FE9-456E-BBCF-442D2B8ACFEB}"/>
+                <a16:creationId xmlns:a16="http://schemas.microsoft.com/office/drawing/2014/main" id="{52DF642F-0601-4AF7-BCC6-3B92ACC0AF01}"/>
               </a:ext>
             </a:extLst>
           </p:cNvPr>
@@ -5939,7 +5962,7 @@
           <p:cNvPr id="4" name="">
             <a:extLst xmlns:a="http://schemas.openxmlformats.org/drawingml/2006/main">
               <a:ext uri="{FF2B5EF4-FFF2-40B4-BE49-F238E27FC236}">
-                <a16:creationId xmlns:a16="http://schemas.microsoft.com/office/drawing/2014/main" id="{8577D3CC-E4AA-4D58-94FE-77A99F92BF17}"/>
+                <a16:creationId xmlns:a16="http://schemas.microsoft.com/office/drawing/2014/main" id="{37E95FFB-DB2D-48F2-A073-8B3D5B556813}"/>
               </a:ext>
             </a:extLst>
           </p:cNvPr>
@@ -6008,7 +6031,7 @@
           <p:cNvPr id="5" name="">
             <a:extLst xmlns:a="http://schemas.openxmlformats.org/drawingml/2006/main">
               <a:ext uri="{FF2B5EF4-FFF2-40B4-BE49-F238E27FC236}">
-                <a16:creationId xmlns:a16="http://schemas.microsoft.com/office/drawing/2014/main" id="{D16D6BE5-A23A-44EF-B3AC-777F87C458F1}"/>
+                <a16:creationId xmlns:a16="http://schemas.microsoft.com/office/drawing/2014/main" id="{8EB5B5EC-3765-47C6-A347-FF1D4902D6AB}"/>
               </a:ext>
             </a:extLst>
           </p:cNvPr>
@@ -6077,7 +6100,7 @@
           <p:cNvPr id="6" name="">
             <a:extLst xmlns:a="http://schemas.openxmlformats.org/drawingml/2006/main">
               <a:ext uri="{FF2B5EF4-FFF2-40B4-BE49-F238E27FC236}">
-                <a16:creationId xmlns:a16="http://schemas.microsoft.com/office/drawing/2014/main" id="{20B00DBC-6CAA-4404-9E98-423085D90710}"/>
+                <a16:creationId xmlns:a16="http://schemas.microsoft.com/office/drawing/2014/main" id="{89095BAC-FD9D-4940-B003-D83A54611C15}"/>
               </a:ext>
             </a:extLst>
           </p:cNvPr>
@@ -6146,7 +6169,7 @@
           <p:cNvPr id="7" name="">
             <a:extLst xmlns:a="http://schemas.openxmlformats.org/drawingml/2006/main">
               <a:ext uri="{FF2B5EF4-FFF2-40B4-BE49-F238E27FC236}">
-                <a16:creationId xmlns:a16="http://schemas.microsoft.com/office/drawing/2014/main" id="{1AEE100D-6E65-48D4-8B0A-7D7F88295642}"/>
+                <a16:creationId xmlns:a16="http://schemas.microsoft.com/office/drawing/2014/main" id="{3CE7F249-6676-4990-BC17-DEC899080640}"/>
               </a:ext>
             </a:extLst>
           </p:cNvPr>
@@ -6215,7 +6238,7 @@
           <p:cNvPr id="8" name="">
             <a:extLst xmlns:a="http://schemas.openxmlformats.org/drawingml/2006/main">
               <a:ext uri="{FF2B5EF4-FFF2-40B4-BE49-F238E27FC236}">
-                <a16:creationId xmlns:a16="http://schemas.microsoft.com/office/drawing/2014/main" id="{A5364BB1-984D-4254-8E97-5D6F30C1A4B4}"/>
+                <a16:creationId xmlns:a16="http://schemas.microsoft.com/office/drawing/2014/main" id="{694709FD-0CB4-4FB6-AD83-0E44570D3E71}"/>
               </a:ext>
             </a:extLst>
           </p:cNvPr>
@@ -6284,7 +6307,7 @@
           <p:cNvPr id="9" name="">
             <a:extLst xmlns:a="http://schemas.openxmlformats.org/drawingml/2006/main">
               <a:ext uri="{FF2B5EF4-FFF2-40B4-BE49-F238E27FC236}">
-                <a16:creationId xmlns:a16="http://schemas.microsoft.com/office/drawing/2014/main" id="{E2CF1473-E87D-4A63-B863-AB503E213556}"/>
+                <a16:creationId xmlns:a16="http://schemas.microsoft.com/office/drawing/2014/main" id="{1B606414-B215-4D8B-8436-AA92E78C382C}"/>
               </a:ext>
             </a:extLst>
           </p:cNvPr>
@@ -6294,7 +6317,7 @@
           <p:nvPr/>
         </p:nvPicPr>
         <p:blipFill>
-          <a:blip xmlns:r="http://schemas.openxmlformats.org/officeDocument/2006/relationships" xmlns:a="http://schemas.openxmlformats.org/drawingml/2006/main" r:embed="R0fe1545247164721"/>
+          <a:blip xmlns:r="http://schemas.openxmlformats.org/officeDocument/2006/relationships" xmlns:a="http://schemas.openxmlformats.org/drawingml/2006/main" r:embed="Rbf0a021f48c4427d"/>
           <a:stretch xmlns:a="http://schemas.openxmlformats.org/drawingml/2006/main"/>
         </p:blipFill>
         <p:spPr>
@@ -6312,7 +6335,7 @@
           <p:cNvPr id="10" name="">
             <a:extLst xmlns:a="http://schemas.openxmlformats.org/drawingml/2006/main">
               <a:ext uri="{FF2B5EF4-FFF2-40B4-BE49-F238E27FC236}">
-                <a16:creationId xmlns:a16="http://schemas.microsoft.com/office/drawing/2014/main" id="{8F2F17D3-2080-455A-A45D-15D1F6E12417}"/>
+                <a16:creationId xmlns:a16="http://schemas.microsoft.com/office/drawing/2014/main" id="{D36CFE32-0D0C-4DC0-84E3-AD720B7661CE}"/>
               </a:ext>
             </a:extLst>
           </p:cNvPr>
@@ -6322,7 +6345,7 @@
           <p:nvPr/>
         </p:nvPicPr>
         <p:blipFill>
-          <a:blip xmlns:r="http://schemas.openxmlformats.org/officeDocument/2006/relationships" xmlns:a="http://schemas.openxmlformats.org/drawingml/2006/main" r:embed="Rb141184480854829"/>
+          <a:blip xmlns:r="http://schemas.openxmlformats.org/officeDocument/2006/relationships" xmlns:a="http://schemas.openxmlformats.org/drawingml/2006/main" r:embed="R65ebc3a016054394"/>
           <a:stretch xmlns:a="http://schemas.openxmlformats.org/drawingml/2006/main"/>
         </p:blipFill>
         <p:spPr>
@@ -6340,7 +6363,7 @@
           <p:cNvPr id="11" name="">
             <a:extLst xmlns:a="http://schemas.openxmlformats.org/drawingml/2006/main">
               <a:ext uri="{FF2B5EF4-FFF2-40B4-BE49-F238E27FC236}">
-                <a16:creationId xmlns:a16="http://schemas.microsoft.com/office/drawing/2014/main" id="{585A2D38-126F-4D75-930D-0D6CA991BE12}"/>
+                <a16:creationId xmlns:a16="http://schemas.microsoft.com/office/drawing/2014/main" id="{2210D06F-E880-4606-B96E-D37BAC0E86AE}"/>
               </a:ext>
             </a:extLst>
           </p:cNvPr>
@@ -6350,7 +6373,7 @@
           <p:nvPr/>
         </p:nvPicPr>
         <p:blipFill>
-          <a:blip xmlns:r="http://schemas.openxmlformats.org/officeDocument/2006/relationships" xmlns:a="http://schemas.openxmlformats.org/drawingml/2006/main" r:embed="Rfd71726878194350"/>
+          <a:blip xmlns:r="http://schemas.openxmlformats.org/officeDocument/2006/relationships" xmlns:a="http://schemas.openxmlformats.org/drawingml/2006/main" r:embed="R56df4d0949a047a9"/>
           <a:stretch xmlns:a="http://schemas.openxmlformats.org/drawingml/2006/main"/>
         </p:blipFill>
         <p:spPr>
@@ -6368,7 +6391,7 @@
           <p:cNvPr id="12" name="">
             <a:extLst xmlns:a="http://schemas.openxmlformats.org/drawingml/2006/main">
               <a:ext uri="{FF2B5EF4-FFF2-40B4-BE49-F238E27FC236}">
-                <a16:creationId xmlns:a16="http://schemas.microsoft.com/office/drawing/2014/main" id="{2F8A748D-5E22-4AE0-BEDB-27D104457E52}"/>
+                <a16:creationId xmlns:a16="http://schemas.microsoft.com/office/drawing/2014/main" id="{3E341630-AD6B-448C-87B8-75879CE6D1E6}"/>
               </a:ext>
             </a:extLst>
           </p:cNvPr>
@@ -6483,7 +6506,7 @@
           <p:cNvPr id="13" name="">
             <a:extLst xmlns:a="http://schemas.openxmlformats.org/drawingml/2006/main">
               <a:ext uri="{FF2B5EF4-FFF2-40B4-BE49-F238E27FC236}">
-                <a16:creationId xmlns:a16="http://schemas.microsoft.com/office/drawing/2014/main" id="{0C0230B7-2D2B-4372-B7A1-43D2200E7B3E}"/>
+                <a16:creationId xmlns:a16="http://schemas.microsoft.com/office/drawing/2014/main" id="{BC4ED9E9-1C0C-4F25-B8DD-5778C826F3EA}"/>
               </a:ext>
             </a:extLst>
           </p:cNvPr>
@@ -6598,7 +6621,7 @@
           <p:cNvPr id="14" name="">
             <a:extLst xmlns:a="http://schemas.openxmlformats.org/drawingml/2006/main">
               <a:ext uri="{FF2B5EF4-FFF2-40B4-BE49-F238E27FC236}">
-                <a16:creationId xmlns:a16="http://schemas.microsoft.com/office/drawing/2014/main" id="{62176768-9869-46BF-8194-468AF677CD0A}"/>
+                <a16:creationId xmlns:a16="http://schemas.microsoft.com/office/drawing/2014/main" id="{7946499D-6C22-4A5D-ABE8-503CB9FB3F2E}"/>
               </a:ext>
             </a:extLst>
           </p:cNvPr>
@@ -6711,7 +6734,7 @@
     </p:spTree>
     <p:extLst>
       <p:ext uri="{BB962C8B-B14F-4D97-AF65-F5344CB8AC3E}">
-        <p14:creationId xmlns:p14="http://schemas.microsoft.com/office/powerpoint/2010/main" val="865186744"/>
+        <p14:creationId xmlns:p14="http://schemas.microsoft.com/office/powerpoint/2010/main" val="247656820"/>
       </p:ext>
     </p:extLst>
   </p:cSld>
@@ -6742,7 +6765,7 @@
           <p:cNvPr id="10" name="">
             <a:extLst xmlns:a="http://schemas.openxmlformats.org/drawingml/2006/main">
               <a:ext uri="{FF2B5EF4-FFF2-40B4-BE49-F238E27FC236}">
-                <a16:creationId xmlns:a16="http://schemas.microsoft.com/office/drawing/2014/main" id="{1031C314-E538-4C03-BA49-A241848F64F0}"/>
+                <a16:creationId xmlns:a16="http://schemas.microsoft.com/office/drawing/2014/main" id="{277F4CCB-67D3-4B97-A074-559F379B5726}"/>
               </a:ext>
             </a:extLst>
           </p:cNvPr>
@@ -6811,7 +6834,7 @@
           <p:cNvPr id="2" name="">
             <a:extLst xmlns:a="http://schemas.openxmlformats.org/drawingml/2006/main">
               <a:ext uri="{FF2B5EF4-FFF2-40B4-BE49-F238E27FC236}">
-                <a16:creationId xmlns:a16="http://schemas.microsoft.com/office/drawing/2014/main" id="{E49CADE9-CC8A-4FB4-840A-111C27A26411}"/>
+                <a16:creationId xmlns:a16="http://schemas.microsoft.com/office/drawing/2014/main" id="{1DE4CD3B-252B-44AB-B0A8-E056EAEA079C}"/>
               </a:ext>
             </a:extLst>
           </p:cNvPr>
@@ -6880,7 +6903,7 @@
           <p:cNvPr id="3" name="">
             <a:extLst xmlns:a="http://schemas.openxmlformats.org/drawingml/2006/main">
               <a:ext uri="{FF2B5EF4-FFF2-40B4-BE49-F238E27FC236}">
-                <a16:creationId xmlns:a16="http://schemas.microsoft.com/office/drawing/2014/main" id="{16E74437-69EA-4E4F-B37E-2CD432C8033D}"/>
+                <a16:creationId xmlns:a16="http://schemas.microsoft.com/office/drawing/2014/main" id="{FFE7378A-DB14-4990-BE4D-4DCC82BA9443}"/>
               </a:ext>
             </a:extLst>
           </p:cNvPr>
@@ -6890,7 +6913,7 @@
           <p:nvPr/>
         </p:nvPicPr>
         <p:blipFill>
-          <a:blip xmlns:r="http://schemas.openxmlformats.org/officeDocument/2006/relationships" xmlns:a="http://schemas.openxmlformats.org/drawingml/2006/main" r:embed="R631de31c43564de3"/>
+          <a:blip xmlns:r="http://schemas.openxmlformats.org/officeDocument/2006/relationships" xmlns:a="http://schemas.openxmlformats.org/drawingml/2006/main" r:embed="Rf500820161fc4dbb"/>
           <a:stretch xmlns:a="http://schemas.openxmlformats.org/drawingml/2006/main"/>
         </p:blipFill>
         <p:spPr>
@@ -6908,7 +6931,7 @@
           <p:cNvPr id="4" name="">
             <a:extLst xmlns:a="http://schemas.openxmlformats.org/drawingml/2006/main">
               <a:ext uri="{FF2B5EF4-FFF2-40B4-BE49-F238E27FC236}">
-                <a16:creationId xmlns:a16="http://schemas.microsoft.com/office/drawing/2014/main" id="{FCE16820-E36A-4AD8-80B5-3502F3C7283F}"/>
+                <a16:creationId xmlns:a16="http://schemas.microsoft.com/office/drawing/2014/main" id="{0D4ABF7A-F56F-491F-B4D7-66A9C7419D9F}"/>
               </a:ext>
             </a:extLst>
           </p:cNvPr>
@@ -6918,7 +6941,7 @@
           <p:nvPr/>
         </p:nvPicPr>
         <p:blipFill>
-          <a:blip xmlns:r="http://schemas.openxmlformats.org/officeDocument/2006/relationships" xmlns:a="http://schemas.openxmlformats.org/drawingml/2006/main" r:embed="R49e0596575b1497b"/>
+          <a:blip xmlns:r="http://schemas.openxmlformats.org/officeDocument/2006/relationships" xmlns:a="http://schemas.openxmlformats.org/drawingml/2006/main" r:embed="R45b9f7249dac412f"/>
           <a:stretch xmlns:a="http://schemas.openxmlformats.org/drawingml/2006/main"/>
         </p:blipFill>
         <p:spPr>
@@ -6936,7 +6959,7 @@
           <p:cNvPr id="5" name="">
             <a:extLst xmlns:a="http://schemas.openxmlformats.org/drawingml/2006/main">
               <a:ext uri="{FF2B5EF4-FFF2-40B4-BE49-F238E27FC236}">
-                <a16:creationId xmlns:a16="http://schemas.microsoft.com/office/drawing/2014/main" id="{70521CF4-2324-4263-B202-F3F41DB2B7CB}"/>
+                <a16:creationId xmlns:a16="http://schemas.microsoft.com/office/drawing/2014/main" id="{35720C57-A5BE-455A-BD0A-3A9AB9BD2157}"/>
               </a:ext>
             </a:extLst>
           </p:cNvPr>
@@ -6946,7 +6969,7 @@
           <p:nvPr/>
         </p:nvPicPr>
         <p:blipFill>
-          <a:blip xmlns:r="http://schemas.openxmlformats.org/officeDocument/2006/relationships" xmlns:a="http://schemas.openxmlformats.org/drawingml/2006/main" r:embed="R6c2b527a09864f83"/>
+          <a:blip xmlns:r="http://schemas.openxmlformats.org/officeDocument/2006/relationships" xmlns:a="http://schemas.openxmlformats.org/drawingml/2006/main" r:embed="R16d5bd1e03974727"/>
           <a:stretch xmlns:a="http://schemas.openxmlformats.org/drawingml/2006/main"/>
         </p:blipFill>
         <p:spPr>
@@ -6964,7 +6987,7 @@
           <p:cNvPr id="6" name="">
             <a:extLst xmlns:a="http://schemas.openxmlformats.org/drawingml/2006/main">
               <a:ext uri="{FF2B5EF4-FFF2-40B4-BE49-F238E27FC236}">
-                <a16:creationId xmlns:a16="http://schemas.microsoft.com/office/drawing/2014/main" id="{F18DDF4D-5523-4F9B-BE5A-7437EC784D41}"/>
+                <a16:creationId xmlns:a16="http://schemas.microsoft.com/office/drawing/2014/main" id="{40B5E8CA-941B-4DB6-99BB-2479783DB79B}"/>
               </a:ext>
             </a:extLst>
           </p:cNvPr>
@@ -7056,7 +7079,7 @@
           <p:cNvPr id="7" name="">
             <a:extLst xmlns:a="http://schemas.openxmlformats.org/drawingml/2006/main">
               <a:ext uri="{FF2B5EF4-FFF2-40B4-BE49-F238E27FC236}">
-                <a16:creationId xmlns:a16="http://schemas.microsoft.com/office/drawing/2014/main" id="{541CABC3-3270-467D-8030-A7A558D835F8}"/>
+                <a16:creationId xmlns:a16="http://schemas.microsoft.com/office/drawing/2014/main" id="{B21693FB-F244-427F-AE7A-17D5548BDFE8}"/>
               </a:ext>
             </a:extLst>
           </p:cNvPr>
@@ -7148,7 +7171,7 @@
           <p:cNvPr id="8" name="">
             <a:extLst xmlns:a="http://schemas.openxmlformats.org/drawingml/2006/main">
               <a:ext uri="{FF2B5EF4-FFF2-40B4-BE49-F238E27FC236}">
-                <a16:creationId xmlns:a16="http://schemas.microsoft.com/office/drawing/2014/main" id="{E93BB553-6A0E-4CF8-BE97-F1A24918F690}"/>
+                <a16:creationId xmlns:a16="http://schemas.microsoft.com/office/drawing/2014/main" id="{3A468031-58C1-4583-9704-7C41B8F17097}"/>
               </a:ext>
             </a:extLst>
           </p:cNvPr>
@@ -7240,7 +7263,7 @@
           <p:cNvPr id="9" name="">
             <a:extLst xmlns:a="http://schemas.openxmlformats.org/drawingml/2006/main">
               <a:ext uri="{FF2B5EF4-FFF2-40B4-BE49-F238E27FC236}">
-                <a16:creationId xmlns:a16="http://schemas.microsoft.com/office/drawing/2014/main" id="{182D930A-D170-4A3D-9B23-3CECC8CC8F1B}"/>
+                <a16:creationId xmlns:a16="http://schemas.microsoft.com/office/drawing/2014/main" id="{4B7A315F-FF35-4478-8AB0-3D569BA57388}"/>
               </a:ext>
             </a:extLst>
           </p:cNvPr>
@@ -7307,7 +7330,7 @@
     </p:spTree>
     <p:extLst>
       <p:ext uri="{BB962C8B-B14F-4D97-AF65-F5344CB8AC3E}">
-        <p14:creationId xmlns:p14="http://schemas.microsoft.com/office/powerpoint/2010/main" val="1123907060"/>
+        <p14:creationId xmlns:p14="http://schemas.microsoft.com/office/powerpoint/2010/main" val="459494329"/>
       </p:ext>
     </p:extLst>
   </p:cSld>
@@ -7338,7 +7361,7 @@
           <p:cNvPr id="6" name="">
             <a:extLst xmlns:a="http://schemas.openxmlformats.org/drawingml/2006/main">
               <a:ext uri="{FF2B5EF4-FFF2-40B4-BE49-F238E27FC236}">
-                <a16:creationId xmlns:a16="http://schemas.microsoft.com/office/drawing/2014/main" id="{B81C7A6A-AC6A-4720-AAF0-5EA402C25151}"/>
+                <a16:creationId xmlns:a16="http://schemas.microsoft.com/office/drawing/2014/main" id="{B9B102C4-B919-49DD-89CB-8F40F4F652E8}"/>
               </a:ext>
             </a:extLst>
           </p:cNvPr>
@@ -7407,7 +7430,7 @@
           <p:cNvPr id="2" name="">
             <a:extLst xmlns:a="http://schemas.openxmlformats.org/drawingml/2006/main">
               <a:ext uri="{FF2B5EF4-FFF2-40B4-BE49-F238E27FC236}">
-                <a16:creationId xmlns:a16="http://schemas.microsoft.com/office/drawing/2014/main" id="{474C6F3D-F74D-4C91-9EFC-73614E397CAD}"/>
+                <a16:creationId xmlns:a16="http://schemas.microsoft.com/office/drawing/2014/main" id="{D58E2D6A-F27B-4820-89F6-E6BAAF5BBBFB}"/>
               </a:ext>
             </a:extLst>
           </p:cNvPr>
@@ -7476,7 +7499,7 @@
           <p:cNvPr id="3" name="">
             <a:extLst xmlns:a="http://schemas.openxmlformats.org/drawingml/2006/main">
               <a:ext uri="{FF2B5EF4-FFF2-40B4-BE49-F238E27FC236}">
-                <a16:creationId xmlns:a16="http://schemas.microsoft.com/office/drawing/2014/main" id="{D38A732A-DDEA-4916-809A-5F000B89F9FB}"/>
+                <a16:creationId xmlns:a16="http://schemas.microsoft.com/office/drawing/2014/main" id="{1B8057A1-8E63-4E6F-A937-2C2F667723EC}"/>
               </a:ext>
             </a:extLst>
           </p:cNvPr>
@@ -7486,7 +7509,7 @@
           <p:nvPr/>
         </p:nvPicPr>
         <p:blipFill>
-          <a:blip xmlns:r="http://schemas.openxmlformats.org/officeDocument/2006/relationships" xmlns:a="http://schemas.openxmlformats.org/drawingml/2006/main" r:embed="R9f05c02cc84f486c"/>
+          <a:blip xmlns:r="http://schemas.openxmlformats.org/officeDocument/2006/relationships" xmlns:a="http://schemas.openxmlformats.org/drawingml/2006/main" r:embed="R41556c33e60845e0"/>
           <a:stretch xmlns:a="http://schemas.openxmlformats.org/drawingml/2006/main"/>
         </p:blipFill>
         <p:spPr>
@@ -7504,7 +7527,7 @@
           <p:cNvPr id="4" name="">
             <a:extLst xmlns:a="http://schemas.openxmlformats.org/drawingml/2006/main">
               <a:ext uri="{FF2B5EF4-FFF2-40B4-BE49-F238E27FC236}">
-                <a16:creationId xmlns:a16="http://schemas.microsoft.com/office/drawing/2014/main" id="{ABC5C081-AD52-4535-9B75-18BE9F7D10D3}"/>
+                <a16:creationId xmlns:a16="http://schemas.microsoft.com/office/drawing/2014/main" id="{A26BB3A3-FE65-44B5-B272-B903B11B64EA}"/>
               </a:ext>
             </a:extLst>
           </p:cNvPr>
@@ -7629,7 +7652,7 @@
           <p:cNvPr id="5" name="">
             <a:extLst xmlns:a="http://schemas.openxmlformats.org/drawingml/2006/main">
               <a:ext uri="{FF2B5EF4-FFF2-40B4-BE49-F238E27FC236}">
-                <a16:creationId xmlns:a16="http://schemas.microsoft.com/office/drawing/2014/main" id="{4731660C-C43C-4A7C-B9B0-C7D5C0D0C055}"/>
+                <a16:creationId xmlns:a16="http://schemas.microsoft.com/office/drawing/2014/main" id="{B5B69F05-E741-4263-98DF-0EF83811A6CC}"/>
               </a:ext>
             </a:extLst>
           </p:cNvPr>
@@ -7742,7 +7765,7 @@
     </p:spTree>
     <p:extLst>
       <p:ext uri="{BB962C8B-B14F-4D97-AF65-F5344CB8AC3E}">
-        <p14:creationId xmlns:p14="http://schemas.microsoft.com/office/powerpoint/2010/main" val="359517383"/>
+        <p14:creationId xmlns:p14="http://schemas.microsoft.com/office/powerpoint/2010/main" val="606047075"/>
       </p:ext>
     </p:extLst>
   </p:cSld>

</xml_diff>